<commit_message>
Update competitor metrics, figures, and presentation files
- Changed recommended provider in competitor_metrics.json from "XY" to "Ninguno".
- Updated the EDA overview figure (01_eda_overview.png).
- Modified the executive presentation file (presentacion_ejecutiva.pptx).
- Updated the compiled Python bytecode for competitor_analysis.
</commit_message>
<xml_diff>
--- a/output/presentacion_ejecutiva.pptx
+++ b/output/presentacion_ejecutiva.pptx
@@ -3616,7 +3616,7 @@
               </a:defRPr>
             </a:pPr>
             <a:r>
-              <a:t>1/9</a:t>
+              <a:t>1/10</a:t>
             </a:r>
           </a:p>
         </p:txBody>
@@ -4253,7 +4253,7 @@
               </a:defRPr>
             </a:pPr>
             <a:r>
-              <a:t>2/9</a:t>
+              <a:t>2/10</a:t>
             </a:r>
           </a:p>
         </p:txBody>
@@ -4933,7 +4933,7 @@
               </a:defRPr>
             </a:pPr>
             <a:r>
-              <a:t>3/9</a:t>
+              <a:t>3/10</a:t>
             </a:r>
           </a:p>
         </p:txBody>
@@ -5749,7 +5749,7 @@
               </a:defRPr>
             </a:pPr>
             <a:r>
-              <a:t>4/9</a:t>
+              <a:t>4/10</a:t>
             </a:r>
           </a:p>
         </p:txBody>
@@ -6609,7 +6609,7 @@
               </a:defRPr>
             </a:pPr>
             <a:r>
-              <a:t>5/9</a:t>
+              <a:t>5/10</a:t>
             </a:r>
           </a:p>
         </p:txBody>
@@ -7493,7 +7493,7 @@
               </a:defRPr>
             </a:pPr>
             <a:r>
-              <a:t>6/9</a:t>
+              <a:t>6/10</a:t>
             </a:r>
           </a:p>
         </p:txBody>
@@ -7907,7 +7907,7 @@
               </a:defRPr>
             </a:pPr>
             <a:r>
-              <a:t>7/9</a:t>
+              <a:t>7/10</a:t>
             </a:r>
           </a:p>
         </p:txBody>
@@ -8527,7 +8527,7 @@
               </a:defRPr>
             </a:pPr>
             <a:r>
-              <a:t>8/9</a:t>
+              <a:t>8/10</a:t>
             </a:r>
           </a:p>
         </p:txBody>

</xml_diff>

<commit_message>
fix: corregir bugs críticos en modelo y análisis de proveedores
- Corregir inconsistencia en recomendación de proveedores (notebook 03
  coincidía con script: no contratar a ninguno, AUC≈0.50)
- Eliminar código de impresión duplicado en model_building.py
- Corregir f-strings sin interpolar en reporte PDF
- Agregar StandardScaler para coeficientes comparables en Logistic Regression
- Corregir branches idénticos en calculate_lift (competitor_analysis.py)
- Agregar pd.to_datetime faltante en notebook 03
- Reemplazar +1 artificial en feature engineering por mediana de valores
- Incluir scaler en modelo serializado (output/model.pkl)
</commit_message>
<xml_diff>
--- a/output/presentacion_ejecutiva.pptx
+++ b/output/presentacion_ejecutiva.pptx
@@ -5167,7 +5167,7 @@
               </a:defRPr>
             </a:pPr>
             <a:r>
-              <a:t>0.61</a:t>
+              <a:t>0.62</a:t>
             </a:r>
           </a:p>
         </p:txBody>
@@ -5322,7 +5322,7 @@
               </a:defRPr>
             </a:pPr>
             <a:r>
-              <a:t>59%</a:t>
+              <a:t>63%</a:t>
             </a:r>
           </a:p>
         </p:txBody>
@@ -5477,7 +5477,7 @@
               </a:defRPr>
             </a:pPr>
             <a:r>
-              <a:t>53%</a:t>
+              <a:t>50%</a:t>
             </a:r>
           </a:p>
         </p:txBody>

</xml_diff>